<commit_message>
docs(14): CP2-CP4 -- screenshots closed, models slide, docs and Pages link rewrite
CP2 and CP3 closed on the user's approval; CP4 (documents) done and CP5
(final review) prepared, both awaiting the user. Deck is now 13 slides
(new models slide from REPORT section 7, expanded login/403 slide, usernames
and Segoe UI). README links the deck; approved deviations recorded in
CLAUDE.md, AGENTS.md and SPEC rows 13/14; PHASE13 appendix heading closed;
.nojekyll plus a Pages-only doc-link rewrite in ROADMAP.html with a focused
test. screen_shots/ stays untracked; no requirement status changed.

Co-Authored-By: Claude Sonnet 5.5 <noreply@anthropic.com>
</commit_message>
<xml_diff>
--- a/docs/presentation/FunnelIQ.pptx
+++ b/docs/presentation/FunnelIQ.pptx
@@ -17,6 +17,7 @@
     <p:sldId id="265" r:id="rId17"/>
     <p:sldId id="266" r:id="rId18"/>
     <p:sldId id="267" r:id="rId19"/>
+    <p:sldId id="268" r:id="rId20"/>
   </p:sldIdLst>
   <p:sldSz cx="12191695" cy="6858000" type="screen4x3"/>
   <p:notesSz cx="6858000" cy="9144000"/>
@@ -653,7 +654,7 @@
           <a:lstStyle/>
           <a:p>
             <a:r>
-              <a:t>מקור: README, ROADMAP פאזה 3-4. הצילום חתוך רק בשטח הלבן שמתחת לתוכן. בלי סיסמאות או טוקנים (D5).</a:t>
+              <a:t>מקור: REPORT.md §7 (בחירת מודל, כלל One-SE), §2-§6 (הרצת המודלים), §9 (כיול sigmoid, SHAP; טווחי ביטחון: conformal ב-P2, bootstrap בתקציב). משימות פנימיות: P2, P3, P4, P4S, P6.</a:t>
             </a:r>
           </a:p>
         </p:txBody>
@@ -679,6 +680,76 @@
 </file>
 
 <file path=ppt/notesSlides/notesSlide12.xml><?xml version="1.0" encoding="utf-8"?>
+<p:notes xmlns:a="http://schemas.openxmlformats.org/drawingml/2006/main" xmlns:p="http://schemas.openxmlformats.org/presentationml/2006/main" xmlns:r="http://schemas.openxmlformats.org/officeDocument/2006/relationships">
+  <p:cSld>
+    <p:spTree>
+      <p:nvGrpSpPr>
+        <p:cNvPr id="1" name=""/>
+        <p:cNvGrpSpPr/>
+        <p:nvPr/>
+      </p:nvGrpSpPr>
+      <p:grpSpPr>
+        <a:xfrm>
+          <a:off x="0" y="0"/>
+          <a:ext cx="0" cy="0"/>
+          <a:chOff x="0" y="0"/>
+          <a:chExt cx="0" cy="0"/>
+        </a:xfrm>
+      </p:grpSpPr>
+      <p:sp>
+        <p:nvSpPr>
+          <p:cNvPr id="2" name="Slide Image Placeholder 1"/>
+          <p:cNvSpPr>
+            <a:spLocks noGrp="1"/>
+          </p:cNvSpPr>
+          <p:nvPr>
+            <p:ph type="sldImg" idx="2"/>
+          </p:nvPr>
+        </p:nvSpPr>
+        <p:spPr/>
+      </p:sp>
+      <p:sp>
+        <p:nvSpPr>
+          <p:cNvPr id="3" name="Notes Placeholder 2"/>
+          <p:cNvSpPr>
+            <a:spLocks noGrp="1"/>
+          </p:cNvSpPr>
+          <p:nvPr>
+            <p:ph type="body" idx="3" sz="quarter"/>
+          </p:nvPr>
+        </p:nvSpPr>
+        <p:spPr/>
+        <p:txBody>
+          <a:bodyPr/>
+          <a:lstStyle/>
+          <a:p>
+            <a:r>
+              <a:t>מקור: README, ROADMAP פאזה 3-4. הצילום חתוך רק בשטח הלבן שמתחת לתוכן. בלי סיסמאות או טוקנים (D5).</a:t>
+            </a:r>
+          </a:p>
+        </p:txBody>
+      </p:sp>
+      <p:sp>
+        <p:nvSpPr>
+          <p:cNvPr id="4" name="Slide Number Placeholder 3"/>
+          <p:cNvSpPr>
+            <a:spLocks noGrp="1"/>
+          </p:cNvSpPr>
+          <p:nvPr>
+            <p:ph type="sldNum" idx="5" sz="quarter"/>
+          </p:nvPr>
+        </p:nvSpPr>
+        <p:spPr/>
+      </p:sp>
+    </p:spTree>
+  </p:cSld>
+  <p:clrMapOvr>
+    <a:masterClrMapping/>
+  </p:clrMapOvr>
+</p:notes>
+</file>
+
+<file path=ppt/notesSlides/notesSlide13.xml><?xml version="1.0" encoding="utf-8"?>
 <p:notes xmlns:a="http://schemas.openxmlformats.org/drawingml/2006/main" xmlns:p="http://schemas.openxmlformats.org/presentationml/2006/main" xmlns:r="http://schemas.openxmlformats.org/officeDocument/2006/relationships">
   <p:cSld>
     <p:spTree>
@@ -4993,6 +5064,889 @@
                 <a:latin typeface="Segoe UI"/>
                 <a:cs typeface="Segoe UI"/>
               </a:rPr>
+              <a:t>המודלים שמאחורי התשובות</a:t>
+            </a:r>
+          </a:p>
+        </p:txBody>
+      </p:sp>
+      <p:sp>
+        <p:nvSpPr>
+          <p:cNvPr id="4" name="Rounded Rectangle 3"/>
+          <p:cNvSpPr/>
+          <p:nvPr/>
+        </p:nvSpPr>
+        <p:spPr>
+          <a:xfrm>
+            <a:off x="548640" y="1325880"/>
+            <a:ext cx="11064240" cy="822960"/>
+          </a:xfrm>
+          <a:prstGeom prst="roundRect">
+            <a:avLst>
+              <a:gd name="adj" fmla="val 8000"/>
+            </a:avLst>
+          </a:prstGeom>
+          <a:solidFill>
+            <a:srgbClr val="EEF2FF"/>
+          </a:solidFill>
+          <a:ln>
+            <a:noFill/>
+          </a:ln>
+        </p:spPr>
+        <p:style>
+          <a:lnRef idx="1">
+            <a:schemeClr val="accent1"/>
+          </a:lnRef>
+          <a:fillRef idx="3">
+            <a:schemeClr val="accent1"/>
+          </a:fillRef>
+          <a:effectRef idx="2">
+            <a:schemeClr val="accent1"/>
+          </a:effectRef>
+          <a:fontRef idx="minor">
+            <a:schemeClr val="lt1"/>
+          </a:fontRef>
+        </p:style>
+        <p:txBody>
+          <a:bodyPr rtlCol="0" anchor="ctr" lIns="182880" rIns="182880" wrap="square"/>
+          <a:lstStyle/>
+          <a:p>
+            <a:pPr algn="r" rtl="1">
+              <a:spcAft>
+                <a:spcPts val="600"/>
+              </a:spcAft>
+            </a:pPr>
+            <a:r>
+              <a:rPr sz="2200" b="1" lang="he-IL">
+                <a:solidFill>
+                  <a:srgbClr val="2563EB"/>
+                </a:solidFill>
+                <a:latin typeface="Segoe UI"/>
+                <a:cs typeface="Segoe UI"/>
+              </a:rPr>
+              <a:t>משך חיי לקוח — </a:t>
+            </a:r>
+            <a:r>
+              <a:rPr sz="2200" b="1" lang="he-IL">
+                <a:solidFill>
+                  <a:srgbClr val="1A1A1A"/>
+                </a:solidFill>
+                <a:latin typeface="Segoe UI"/>
+                <a:cs typeface="Segoe UI"/>
+              </a:rPr>
+              <a:t>CatBoost</a:t>
+            </a:r>
+          </a:p>
+          <a:p>
+            <a:pPr algn="r" rtl="1">
+              <a:spcAft>
+                <a:spcPts val="600"/>
+              </a:spcAft>
+            </a:pPr>
+            <a:r>
+              <a:rPr sz="1800" b="0" lang="he-IL">
+                <a:solidFill>
+                  <a:srgbClr val="4B5563"/>
+                </a:solidFill>
+                <a:latin typeface="Segoe UI"/>
+                <a:cs typeface="Segoe UI"/>
+              </a:rPr>
+              <a:t>הושוו גם רגרסיה לינארית, ניחוש הממוצע, XGBoost ו-LightGBM; ההבדלים בין העצים זניחים</a:t>
+            </a:r>
+          </a:p>
+        </p:txBody>
+      </p:sp>
+      <p:sp>
+        <p:nvSpPr>
+          <p:cNvPr id="5" name="Rounded Rectangle 4"/>
+          <p:cNvSpPr/>
+          <p:nvPr/>
+        </p:nvSpPr>
+        <p:spPr>
+          <a:xfrm>
+            <a:off x="548640" y="2240280"/>
+            <a:ext cx="11064240" cy="822960"/>
+          </a:xfrm>
+          <a:prstGeom prst="roundRect">
+            <a:avLst>
+              <a:gd name="adj" fmla="val 8000"/>
+            </a:avLst>
+          </a:prstGeom>
+          <a:solidFill>
+            <a:srgbClr val="EEF2FF"/>
+          </a:solidFill>
+          <a:ln>
+            <a:noFill/>
+          </a:ln>
+        </p:spPr>
+        <p:style>
+          <a:lnRef idx="1">
+            <a:schemeClr val="accent1"/>
+          </a:lnRef>
+          <a:fillRef idx="3">
+            <a:schemeClr val="accent1"/>
+          </a:fillRef>
+          <a:effectRef idx="2">
+            <a:schemeClr val="accent1"/>
+          </a:effectRef>
+          <a:fontRef idx="minor">
+            <a:schemeClr val="lt1"/>
+          </a:fontRef>
+        </p:style>
+        <p:txBody>
+          <a:bodyPr rtlCol="0" anchor="ctr" lIns="182880" rIns="182880" wrap="square"/>
+          <a:lstStyle/>
+          <a:p>
+            <a:pPr algn="r" rtl="1">
+              <a:spcAft>
+                <a:spcPts val="600"/>
+              </a:spcAft>
+            </a:pPr>
+            <a:r>
+              <a:rPr sz="2200" b="1" lang="he-IL">
+                <a:solidFill>
+                  <a:srgbClr val="2563EB"/>
+                </a:solidFill>
+                <a:latin typeface="Segoe UI"/>
+                <a:cs typeface="Segoe UI"/>
+              </a:rPr>
+              <a:t>הסתברות לרכישה נוספת — </a:t>
+            </a:r>
+            <a:r>
+              <a:rPr sz="2200" b="1" lang="he-IL">
+                <a:solidFill>
+                  <a:srgbClr val="1A1A1A"/>
+                </a:solidFill>
+                <a:latin typeface="Segoe UI"/>
+                <a:cs typeface="Segoe UI"/>
+              </a:rPr>
+              <a:t>XGBoost</a:t>
+            </a:r>
+          </a:p>
+          <a:p>
+            <a:pPr algn="r" rtl="1">
+              <a:spcAft>
+                <a:spcPts val="600"/>
+              </a:spcAft>
+            </a:pPr>
+            <a:r>
+              <a:rPr sz="1800" b="0" lang="he-IL">
+                <a:solidFill>
+                  <a:srgbClr val="4B5563"/>
+                </a:solidFill>
+                <a:latin typeface="Segoe UI"/>
+                <a:cs typeface="Segoe UI"/>
+              </a:rPr>
+              <a:t>הושוו גם רגרסיה לוגיסטית, CatBoost ו-LightGBM</a:t>
+            </a:r>
+          </a:p>
+        </p:txBody>
+      </p:sp>
+      <p:sp>
+        <p:nvSpPr>
+          <p:cNvPr id="6" name="Rounded Rectangle 5"/>
+          <p:cNvSpPr/>
+          <p:nvPr/>
+        </p:nvSpPr>
+        <p:spPr>
+          <a:xfrm>
+            <a:off x="548640" y="3154680"/>
+            <a:ext cx="11064240" cy="822960"/>
+          </a:xfrm>
+          <a:prstGeom prst="roundRect">
+            <a:avLst>
+              <a:gd name="adj" fmla="val 8000"/>
+            </a:avLst>
+          </a:prstGeom>
+          <a:solidFill>
+            <a:srgbClr val="EEF2FF"/>
+          </a:solidFill>
+          <a:ln>
+            <a:noFill/>
+          </a:ln>
+        </p:spPr>
+        <p:style>
+          <a:lnRef idx="1">
+            <a:schemeClr val="accent1"/>
+          </a:lnRef>
+          <a:fillRef idx="3">
+            <a:schemeClr val="accent1"/>
+          </a:fillRef>
+          <a:effectRef idx="2">
+            <a:schemeClr val="accent1"/>
+          </a:effectRef>
+          <a:fontRef idx="minor">
+            <a:schemeClr val="lt1"/>
+          </a:fontRef>
+        </p:style>
+        <p:txBody>
+          <a:bodyPr rtlCol="0" anchor="ctr" lIns="182880" rIns="182880" wrap="square"/>
+          <a:lstStyle/>
+          <a:p>
+            <a:pPr algn="r" rtl="1">
+              <a:spcAft>
+                <a:spcPts val="600"/>
+              </a:spcAft>
+            </a:pPr>
+            <a:r>
+              <a:rPr sz="2200" b="1" lang="he-IL">
+                <a:solidFill>
+                  <a:srgbClr val="2563EB"/>
+                </a:solidFill>
+                <a:latin typeface="Segoe UI"/>
+                <a:cs typeface="Segoe UI"/>
+              </a:rPr>
+              <a:t>נטייה להפניה — </a:t>
+            </a:r>
+            <a:r>
+              <a:rPr sz="2200" b="1" lang="he-IL">
+                <a:solidFill>
+                  <a:srgbClr val="1A1A1A"/>
+                </a:solidFill>
+                <a:latin typeface="Segoe UI"/>
+                <a:cs typeface="Segoe UI"/>
+              </a:rPr>
+              <a:t>רגרסיה לוגיסטית</a:t>
+            </a:r>
+          </a:p>
+          <a:p>
+            <a:pPr algn="r" rtl="1">
+              <a:spcAft>
+                <a:spcPts val="600"/>
+              </a:spcAft>
+            </a:pPr>
+            <a:r>
+              <a:rPr sz="1800" b="0" lang="he-IL">
+                <a:solidFill>
+                  <a:srgbClr val="4B5563"/>
+                </a:solidFill>
+                <a:latin typeface="Segoe UI"/>
+                <a:cs typeface="Segoe UI"/>
+              </a:rPr>
+              <a:t>הושווה גם CatBoost; ההפרש בתוך שגיאת התקן, ולכן נבחרה הפשוטה</a:t>
+            </a:r>
+          </a:p>
+        </p:txBody>
+      </p:sp>
+      <p:sp>
+        <p:nvSpPr>
+          <p:cNvPr id="7" name="Rounded Rectangle 6"/>
+          <p:cNvSpPr/>
+          <p:nvPr/>
+        </p:nvSpPr>
+        <p:spPr>
+          <a:xfrm>
+            <a:off x="548640" y="4069080"/>
+            <a:ext cx="11064240" cy="822960"/>
+          </a:xfrm>
+          <a:prstGeom prst="roundRect">
+            <a:avLst>
+              <a:gd name="adj" fmla="val 8000"/>
+            </a:avLst>
+          </a:prstGeom>
+          <a:solidFill>
+            <a:srgbClr val="EEF2FF"/>
+          </a:solidFill>
+          <a:ln>
+            <a:noFill/>
+          </a:ln>
+        </p:spPr>
+        <p:style>
+          <a:lnRef idx="1">
+            <a:schemeClr val="accent1"/>
+          </a:lnRef>
+          <a:fillRef idx="3">
+            <a:schemeClr val="accent1"/>
+          </a:fillRef>
+          <a:effectRef idx="2">
+            <a:schemeClr val="accent1"/>
+          </a:effectRef>
+          <a:fontRef idx="minor">
+            <a:schemeClr val="lt1"/>
+          </a:fontRef>
+        </p:style>
+        <p:txBody>
+          <a:bodyPr rtlCol="0" anchor="ctr" lIns="182880" rIns="182880" wrap="square"/>
+          <a:lstStyle/>
+          <a:p>
+            <a:pPr algn="r" rtl="1">
+              <a:spcAft>
+                <a:spcPts val="600"/>
+              </a:spcAft>
+            </a:pPr>
+            <a:r>
+              <a:rPr sz="2200" b="1" lang="he-IL">
+                <a:solidFill>
+                  <a:srgbClr val="2563EB"/>
+                </a:solidFill>
+                <a:latin typeface="Segoe UI"/>
+                <a:cs typeface="Segoe UI"/>
+              </a:rPr>
+              <a:t>ציון לקוח-על — </a:t>
+            </a:r>
+            <a:r>
+              <a:rPr sz="2200" b="1" lang="he-IL">
+                <a:solidFill>
+                  <a:srgbClr val="1A1A1A"/>
+                </a:solidFill>
+                <a:latin typeface="Segoe UI"/>
+                <a:cs typeface="Segoe UI"/>
+              </a:rPr>
+              <a:t>CatBoost</a:t>
+            </a:r>
+          </a:p>
+          <a:p>
+            <a:pPr algn="r" rtl="1">
+              <a:spcAft>
+                <a:spcPts val="600"/>
+              </a:spcAft>
+            </a:pPr>
+            <a:r>
+              <a:rPr sz="1800" b="0" lang="he-IL">
+                <a:solidFill>
+                  <a:srgbClr val="4B5563"/>
+                </a:solidFill>
+                <a:latin typeface="Segoe UI"/>
+                <a:cs typeface="Segoe UI"/>
+              </a:rPr>
+              <a:t>מודל ייעודי כפי שהבריף דורש, אף שהלוגיסטי היה מעט עדיף ב-CV</a:t>
+            </a:r>
+          </a:p>
+        </p:txBody>
+      </p:sp>
+      <p:sp>
+        <p:nvSpPr>
+          <p:cNvPr id="8" name="Rounded Rectangle 7"/>
+          <p:cNvSpPr/>
+          <p:nvPr/>
+        </p:nvSpPr>
+        <p:spPr>
+          <a:xfrm>
+            <a:off x="548640" y="4983480"/>
+            <a:ext cx="11064240" cy="822960"/>
+          </a:xfrm>
+          <a:prstGeom prst="roundRect">
+            <a:avLst>
+              <a:gd name="adj" fmla="val 8000"/>
+            </a:avLst>
+          </a:prstGeom>
+          <a:solidFill>
+            <a:srgbClr val="EEF2FF"/>
+          </a:solidFill>
+          <a:ln>
+            <a:noFill/>
+          </a:ln>
+        </p:spPr>
+        <p:style>
+          <a:lnRef idx="1">
+            <a:schemeClr val="accent1"/>
+          </a:lnRef>
+          <a:fillRef idx="3">
+            <a:schemeClr val="accent1"/>
+          </a:fillRef>
+          <a:effectRef idx="2">
+            <a:schemeClr val="accent1"/>
+          </a:effectRef>
+          <a:fontRef idx="minor">
+            <a:schemeClr val="lt1"/>
+          </a:fontRef>
+        </p:style>
+        <p:txBody>
+          <a:bodyPr rtlCol="0" anchor="ctr" lIns="182880" rIns="182880" wrap="square"/>
+          <a:lstStyle/>
+          <a:p>
+            <a:pPr algn="r" rtl="1">
+              <a:spcAft>
+                <a:spcPts val="600"/>
+              </a:spcAft>
+            </a:pPr>
+            <a:r>
+              <a:rPr sz="2200" b="1" lang="he-IL">
+                <a:solidFill>
+                  <a:srgbClr val="2563EB"/>
+                </a:solidFill>
+                <a:latin typeface="Segoe UI"/>
+                <a:cs typeface="Segoe UI"/>
+              </a:rPr>
+              <a:t>תקציב ורווח — </a:t>
+            </a:r>
+            <a:r>
+              <a:rPr sz="2200" b="1" lang="he-IL">
+                <a:solidFill>
+                  <a:srgbClr val="1A1A1A"/>
+                </a:solidFill>
+                <a:latin typeface="Segoe UI"/>
+                <a:cs typeface="Segoe UI"/>
+              </a:rPr>
+              <a:t>רגרסיה לינארית</a:t>
+            </a:r>
+          </a:p>
+          <a:p>
+            <a:pPr algn="r" rtl="1">
+              <a:spcAft>
+                <a:spcPts val="600"/>
+              </a:spcAft>
+            </a:pPr>
+            <a:r>
+              <a:rPr sz="1800" b="0" lang="he-IL">
+                <a:solidFill>
+                  <a:srgbClr val="4B5563"/>
+                </a:solidFill>
+                <a:latin typeface="Segoe UI"/>
+                <a:cs typeface="Segoe UI"/>
+              </a:rPr>
+              <a:t>נבחרה לפי כלל One-SE; הושווה גם מודל עצים</a:t>
+            </a:r>
+          </a:p>
+        </p:txBody>
+      </p:sp>
+      <p:sp>
+        <p:nvSpPr>
+          <p:cNvPr id="9" name="TextBox 8"/>
+          <p:cNvSpPr txBox="1"/>
+          <p:nvPr/>
+        </p:nvSpPr>
+        <p:spPr>
+          <a:xfrm>
+            <a:off x="548640" y="5943600"/>
+            <a:ext cx="11064240" cy="731520"/>
+          </a:xfrm>
+          <a:prstGeom prst="rect">
+            <a:avLst/>
+          </a:prstGeom>
+          <a:noFill/>
+        </p:spPr>
+        <p:txBody>
+          <a:bodyPr wrap="square">
+            <a:spAutoFit/>
+          </a:bodyPr>
+          <a:lstStyle/>
+          <a:p>
+            <a:pPr algn="r" rtl="1">
+              <a:spcAft>
+                <a:spcPts val="1200"/>
+              </a:spcAft>
+            </a:pPr>
+            <a:r>
+              <a:rPr sz="1600" b="0" lang="he-IL">
+                <a:solidFill>
+                  <a:srgbClr val="4B5563"/>
+                </a:solidFill>
+                <a:latin typeface="Segoe UI"/>
+                <a:cs typeface="Segoe UI"/>
+              </a:rPr>
+              <a:t>בכל משימה נבדק גם מודל בסיס, ונבחר הפשוט ביותר שבתוך שגיאת תקן אחת מהמוביל. בנוסף: כיול, טווחי ביטחון והסברי SHAP</a:t>
+            </a:r>
+          </a:p>
+        </p:txBody>
+      </p:sp>
+    </p:spTree>
+  </p:cSld>
+  <p:clrMapOvr>
+    <a:masterClrMapping/>
+  </p:clrMapOvr>
+  <p:timing>
+    <p:tnLst>
+      <p:par>
+        <p:cTn id="1" dur="indefinite" restart="never" nodeType="tmRoot">
+          <p:childTnLst>
+            <p:seq concurrent="1" nextAc="seek">
+              <p:cTn id="2" dur="indefinite" nodeType="mainSeq">
+                <p:childTnLst>
+                  <p:par>
+                    <p:cTn id="5" fill="hold">
+                      <p:stCondLst>
+                        <p:cond delay="indefinite"/>
+                      </p:stCondLst>
+                      <p:childTnLst>
+                        <p:par>
+                          <p:cTn id="6" fill="hold">
+                            <p:stCondLst>
+                              <p:cond delay="0"/>
+                            </p:stCondLst>
+                            <p:childTnLst>
+                              <p:par>
+                                <p:cTn id="3" presetID="1" presetClass="entr" presetSubtype="0" fill="hold" grpId="0" nodeType="clickEffect">
+                                  <p:stCondLst>
+                                    <p:cond delay="0"/>
+                                  </p:stCondLst>
+                                  <p:childTnLst>
+                                    <p:set>
+                                      <p:cBhvr>
+                                        <p:cTn id="4" dur="1" fill="hold">
+                                          <p:stCondLst>
+                                            <p:cond delay="0"/>
+                                          </p:stCondLst>
+                                        </p:cTn>
+                                        <p:tgtEl>
+                                          <p:spTgt spid="4"/>
+                                        </p:tgtEl>
+                                        <p:attrNameLst>
+                                          <p:attrName>style.visibility</p:attrName>
+                                        </p:attrNameLst>
+                                      </p:cBhvr>
+                                      <p:to>
+                                        <p:strVal val="visible"/>
+                                      </p:to>
+                                    </p:set>
+                                  </p:childTnLst>
+                                </p:cTn>
+                              </p:par>
+                            </p:childTnLst>
+                          </p:cTn>
+                        </p:par>
+                      </p:childTnLst>
+                    </p:cTn>
+                  </p:par>
+                  <p:par>
+                    <p:cTn id="9" fill="hold">
+                      <p:stCondLst>
+                        <p:cond delay="indefinite"/>
+                      </p:stCondLst>
+                      <p:childTnLst>
+                        <p:par>
+                          <p:cTn id="10" fill="hold">
+                            <p:stCondLst>
+                              <p:cond delay="0"/>
+                            </p:stCondLst>
+                            <p:childTnLst>
+                              <p:par>
+                                <p:cTn id="7" presetID="1" presetClass="entr" presetSubtype="0" fill="hold" grpId="0" nodeType="clickEffect">
+                                  <p:stCondLst>
+                                    <p:cond delay="0"/>
+                                  </p:stCondLst>
+                                  <p:childTnLst>
+                                    <p:set>
+                                      <p:cBhvr>
+                                        <p:cTn id="8" dur="1" fill="hold">
+                                          <p:stCondLst>
+                                            <p:cond delay="0"/>
+                                          </p:stCondLst>
+                                        </p:cTn>
+                                        <p:tgtEl>
+                                          <p:spTgt spid="5"/>
+                                        </p:tgtEl>
+                                        <p:attrNameLst>
+                                          <p:attrName>style.visibility</p:attrName>
+                                        </p:attrNameLst>
+                                      </p:cBhvr>
+                                      <p:to>
+                                        <p:strVal val="visible"/>
+                                      </p:to>
+                                    </p:set>
+                                  </p:childTnLst>
+                                </p:cTn>
+                              </p:par>
+                            </p:childTnLst>
+                          </p:cTn>
+                        </p:par>
+                      </p:childTnLst>
+                    </p:cTn>
+                  </p:par>
+                  <p:par>
+                    <p:cTn id="13" fill="hold">
+                      <p:stCondLst>
+                        <p:cond delay="indefinite"/>
+                      </p:stCondLst>
+                      <p:childTnLst>
+                        <p:par>
+                          <p:cTn id="14" fill="hold">
+                            <p:stCondLst>
+                              <p:cond delay="0"/>
+                            </p:stCondLst>
+                            <p:childTnLst>
+                              <p:par>
+                                <p:cTn id="11" presetID="1" presetClass="entr" presetSubtype="0" fill="hold" grpId="0" nodeType="clickEffect">
+                                  <p:stCondLst>
+                                    <p:cond delay="0"/>
+                                  </p:stCondLst>
+                                  <p:childTnLst>
+                                    <p:set>
+                                      <p:cBhvr>
+                                        <p:cTn id="12" dur="1" fill="hold">
+                                          <p:stCondLst>
+                                            <p:cond delay="0"/>
+                                          </p:stCondLst>
+                                        </p:cTn>
+                                        <p:tgtEl>
+                                          <p:spTgt spid="6"/>
+                                        </p:tgtEl>
+                                        <p:attrNameLst>
+                                          <p:attrName>style.visibility</p:attrName>
+                                        </p:attrNameLst>
+                                      </p:cBhvr>
+                                      <p:to>
+                                        <p:strVal val="visible"/>
+                                      </p:to>
+                                    </p:set>
+                                  </p:childTnLst>
+                                </p:cTn>
+                              </p:par>
+                            </p:childTnLst>
+                          </p:cTn>
+                        </p:par>
+                      </p:childTnLst>
+                    </p:cTn>
+                  </p:par>
+                  <p:par>
+                    <p:cTn id="17" fill="hold">
+                      <p:stCondLst>
+                        <p:cond delay="indefinite"/>
+                      </p:stCondLst>
+                      <p:childTnLst>
+                        <p:par>
+                          <p:cTn id="18" fill="hold">
+                            <p:stCondLst>
+                              <p:cond delay="0"/>
+                            </p:stCondLst>
+                            <p:childTnLst>
+                              <p:par>
+                                <p:cTn id="15" presetID="1" presetClass="entr" presetSubtype="0" fill="hold" grpId="0" nodeType="clickEffect">
+                                  <p:stCondLst>
+                                    <p:cond delay="0"/>
+                                  </p:stCondLst>
+                                  <p:childTnLst>
+                                    <p:set>
+                                      <p:cBhvr>
+                                        <p:cTn id="16" dur="1" fill="hold">
+                                          <p:stCondLst>
+                                            <p:cond delay="0"/>
+                                          </p:stCondLst>
+                                        </p:cTn>
+                                        <p:tgtEl>
+                                          <p:spTgt spid="7"/>
+                                        </p:tgtEl>
+                                        <p:attrNameLst>
+                                          <p:attrName>style.visibility</p:attrName>
+                                        </p:attrNameLst>
+                                      </p:cBhvr>
+                                      <p:to>
+                                        <p:strVal val="visible"/>
+                                      </p:to>
+                                    </p:set>
+                                  </p:childTnLst>
+                                </p:cTn>
+                              </p:par>
+                            </p:childTnLst>
+                          </p:cTn>
+                        </p:par>
+                      </p:childTnLst>
+                    </p:cTn>
+                  </p:par>
+                  <p:par>
+                    <p:cTn id="21" fill="hold">
+                      <p:stCondLst>
+                        <p:cond delay="indefinite"/>
+                      </p:stCondLst>
+                      <p:childTnLst>
+                        <p:par>
+                          <p:cTn id="22" fill="hold">
+                            <p:stCondLst>
+                              <p:cond delay="0"/>
+                            </p:stCondLst>
+                            <p:childTnLst>
+                              <p:par>
+                                <p:cTn id="19" presetID="1" presetClass="entr" presetSubtype="0" fill="hold" grpId="0" nodeType="clickEffect">
+                                  <p:stCondLst>
+                                    <p:cond delay="0"/>
+                                  </p:stCondLst>
+                                  <p:childTnLst>
+                                    <p:set>
+                                      <p:cBhvr>
+                                        <p:cTn id="20" dur="1" fill="hold">
+                                          <p:stCondLst>
+                                            <p:cond delay="0"/>
+                                          </p:stCondLst>
+                                        </p:cTn>
+                                        <p:tgtEl>
+                                          <p:spTgt spid="8"/>
+                                        </p:tgtEl>
+                                        <p:attrNameLst>
+                                          <p:attrName>style.visibility</p:attrName>
+                                        </p:attrNameLst>
+                                      </p:cBhvr>
+                                      <p:to>
+                                        <p:strVal val="visible"/>
+                                      </p:to>
+                                    </p:set>
+                                  </p:childTnLst>
+                                </p:cTn>
+                              </p:par>
+                            </p:childTnLst>
+                          </p:cTn>
+                        </p:par>
+                      </p:childTnLst>
+                    </p:cTn>
+                  </p:par>
+                  <p:par>
+                    <p:cTn id="25" fill="hold">
+                      <p:stCondLst>
+                        <p:cond delay="indefinite"/>
+                      </p:stCondLst>
+                      <p:childTnLst>
+                        <p:par>
+                          <p:cTn id="26" fill="hold">
+                            <p:stCondLst>
+                              <p:cond delay="0"/>
+                            </p:stCondLst>
+                            <p:childTnLst>
+                              <p:par>
+                                <p:cTn id="23" presetID="1" presetClass="entr" presetSubtype="0" fill="hold" grpId="0" nodeType="clickEffect">
+                                  <p:stCondLst>
+                                    <p:cond delay="0"/>
+                                  </p:stCondLst>
+                                  <p:childTnLst>
+                                    <p:set>
+                                      <p:cBhvr>
+                                        <p:cTn id="24" dur="1" fill="hold">
+                                          <p:stCondLst>
+                                            <p:cond delay="0"/>
+                                          </p:stCondLst>
+                                        </p:cTn>
+                                        <p:tgtEl>
+                                          <p:spTgt spid="9">
+                                            <p:txEl>
+                                              <p:pRg st="0" end="0"/>
+                                            </p:txEl>
+                                          </p:spTgt>
+                                        </p:tgtEl>
+                                        <p:attrNameLst>
+                                          <p:attrName>style.visibility</p:attrName>
+                                        </p:attrNameLst>
+                                      </p:cBhvr>
+                                      <p:to>
+                                        <p:strVal val="visible"/>
+                                      </p:to>
+                                    </p:set>
+                                  </p:childTnLst>
+                                </p:cTn>
+                              </p:par>
+                            </p:childTnLst>
+                          </p:cTn>
+                        </p:par>
+                      </p:childTnLst>
+                    </p:cTn>
+                  </p:par>
+                </p:childTnLst>
+              </p:cTn>
+              <p:prevCondLst>
+                <p:cond evt="onPrev" delay="0">
+                  <p:tgtEl>
+                    <p:sldTgt/>
+                  </p:tgtEl>
+                </p:cond>
+              </p:prevCondLst>
+              <p:nextCondLst>
+                <p:cond evt="onNext" delay="0">
+                  <p:tgtEl>
+                    <p:sldTgt/>
+                  </p:tgtEl>
+                </p:cond>
+              </p:nextCondLst>
+            </p:seq>
+          </p:childTnLst>
+        </p:cTn>
+      </p:par>
+    </p:tnLst>
+    <p:bldLst>
+      <p:bldP spid="4" grpId="0" animBg="1"/>
+      <p:bldP spid="5" grpId="0" animBg="1"/>
+      <p:bldP spid="6" grpId="0" animBg="1"/>
+      <p:bldP spid="7" grpId="0" animBg="1"/>
+      <p:bldP spid="8" grpId="0" animBg="1"/>
+      <p:bldP spid="9" grpId="0" build="p"/>
+    </p:bldLst>
+  </p:timing>
+</p:sld>
+</file>
+
+<file path=ppt/slides/slide12.xml><?xml version="1.0" encoding="utf-8"?>
+<p:sld xmlns:a="http://schemas.openxmlformats.org/drawingml/2006/main" xmlns:p="http://schemas.openxmlformats.org/presentationml/2006/main" xmlns:r="http://schemas.openxmlformats.org/officeDocument/2006/relationships">
+  <p:cSld>
+    <p:spTree>
+      <p:nvGrpSpPr>
+        <p:cNvPr id="1" name=""/>
+        <p:cNvGrpSpPr/>
+        <p:nvPr/>
+      </p:nvGrpSpPr>
+      <p:grpSpPr/>
+      <p:sp>
+        <p:nvSpPr>
+          <p:cNvPr id="2" name="Rectangle 1"/>
+          <p:cNvSpPr/>
+          <p:nvPr/>
+        </p:nvSpPr>
+        <p:spPr>
+          <a:xfrm>
+            <a:off x="0" y="0"/>
+            <a:ext cx="12191695" cy="201168"/>
+          </a:xfrm>
+          <a:prstGeom prst="rect">
+            <a:avLst/>
+          </a:prstGeom>
+          <a:solidFill>
+            <a:srgbClr val="2563EB"/>
+          </a:solidFill>
+          <a:ln>
+            <a:noFill/>
+          </a:ln>
+        </p:spPr>
+        <p:style>
+          <a:lnRef idx="1">
+            <a:schemeClr val="accent1"/>
+          </a:lnRef>
+          <a:fillRef idx="3">
+            <a:schemeClr val="accent1"/>
+          </a:fillRef>
+          <a:effectRef idx="2">
+            <a:schemeClr val="accent1"/>
+          </a:effectRef>
+          <a:fontRef idx="minor">
+            <a:schemeClr val="lt1"/>
+          </a:fontRef>
+        </p:style>
+        <p:txBody>
+          <a:bodyPr rtlCol="0" anchor="ctr"/>
+          <a:lstStyle/>
+          <a:p>
+            <a:pPr algn="ctr"/>
+          </a:p>
+        </p:txBody>
+      </p:sp>
+      <p:sp>
+        <p:nvSpPr>
+          <p:cNvPr id="3" name="TextBox 2"/>
+          <p:cNvSpPr txBox="1"/>
+          <p:nvPr/>
+        </p:nvSpPr>
+        <p:spPr>
+          <a:xfrm>
+            <a:off x="548640" y="411480"/>
+            <a:ext cx="11064240" cy="914400"/>
+          </a:xfrm>
+          <a:prstGeom prst="rect">
+            <a:avLst/>
+          </a:prstGeom>
+          <a:noFill/>
+        </p:spPr>
+        <p:txBody>
+          <a:bodyPr wrap="square">
+            <a:spAutoFit/>
+          </a:bodyPr>
+          <a:lstStyle/>
+          <a:p>
+            <a:pPr algn="r" rtl="1">
+              <a:spcAft>
+                <a:spcPts val="1200"/>
+              </a:spcAft>
+            </a:pPr>
+            <a:r>
+              <a:rPr sz="3400" b="1" lang="he-IL">
+                <a:solidFill>
+                  <a:srgbClr val="2563EB"/>
+                </a:solidFill>
+                <a:latin typeface="Segoe UI"/>
+                <a:cs typeface="Segoe UI"/>
+              </a:rPr>
               <a:t>גישה ואבטחה</a:t>
             </a:r>
           </a:p>
@@ -5408,7 +6362,7 @@
 </p:sld>
 </file>
 
-<file path=ppt/slides/slide12.xml><?xml version="1.0" encoding="utf-8"?>
+<file path=ppt/slides/slide13.xml><?xml version="1.0" encoding="utf-8"?>
 <p:sld xmlns:a="http://schemas.openxmlformats.org/drawingml/2006/main" xmlns:p="http://schemas.openxmlformats.org/presentationml/2006/main" xmlns:r="http://schemas.openxmlformats.org/officeDocument/2006/relationships">
   <p:cSld>
     <p:spTree>

</xml_diff>

<commit_message>
docs(14): CP4 closed; Codex CP5 wording fixes in the deck
CP4 closed on the user's approval (PR #51 merged). Deck: slide 3 title
"the five questions and their screens"; slide 11 limits the One-SE rule to
eligible candidates and notes the super-customer exception (REPORT section
7). CP5 stays in review: Codex done, user verified click-reveal and links,
closure pending. screen_shots/ stays untracked.

Co-Authored-By: Claude Sonnet 5.5 <noreply@anthropic.com>
</commit_message>
<xml_diff>
--- a/docs/presentation/FunnelIQ.pptx
+++ b/docs/presentation/FunnelIQ.pptx
@@ -5534,7 +5534,7 @@
                 <a:latin typeface="Segoe UI"/>
                 <a:cs typeface="Segoe UI"/>
               </a:rPr>
-              <a:t>בכל משימה נבדק גם מודל בסיס, ונבחר הפשוט ביותר שבתוך שגיאת תקן אחת מהמוביל. בנוסף: כיול, טווחי ביטחון והסברי SHAP</a:t>
+              <a:t>בכל משימה נבדק גם מודל בסיס. מבין המועמדים הזכאים נבחר הפשוט ביותר לפי כלל One-SE; בציון לקוח-על נבחר CatBoost בהתאם לבריף. בנוסף: כיול, טווחי ביטחון והסברי SHAP</a:t>
             </a:r>
           </a:p>
         </p:txBody>
@@ -7505,7 +7505,7 @@
                 <a:latin typeface="Segoe UI"/>
                 <a:cs typeface="Segoe UI"/>
               </a:rPr>
-              <a:t>המטרה: חמש שאלות, חמישה מסכים</a:t>
+              <a:t>המטרה: חמש השאלות והמסכים שלהן</a:t>
             </a:r>
           </a:p>
         </p:txBody>

</xml_diff>